<commit_message>
Completely refactor strategic decks into premium, non-generic consulting layouts using bold metric highlights, core-to-pivot chevron transitions, and table dashboards
</commit_message>
<xml_diff>
--- a/documents/1_pitch_deck.pptx
+++ b/documents/1_pitch_deck.pptx
@@ -3466,7 +3466,7 @@
         </p:nvSpPr>
         <p:spPr>
           <a:xfrm>
-            <a:off x="548640" y="5623560"/>
+            <a:off x="548640" y="5577840"/>
             <a:ext cx="11094415" cy="594360"/>
           </a:xfrm>
           <a:prstGeom prst="rect">
@@ -3509,7 +3509,7 @@
         </p:nvSpPr>
         <p:spPr>
           <a:xfrm>
-            <a:off x="548640" y="5623560"/>
+            <a:off x="548640" y="5577840"/>
             <a:ext cx="73152" cy="594360"/>
           </a:xfrm>
           <a:prstGeom prst="rect">
@@ -3552,7 +3552,7 @@
         </p:nvSpPr>
         <p:spPr>
           <a:xfrm>
-            <a:off x="731520" y="5669280"/>
+            <a:off x="731520" y="5623560"/>
             <a:ext cx="10698480" cy="502920"/>
           </a:xfrm>
           <a:prstGeom prst="rect">
@@ -3707,7 +3707,7 @@
               </a:defRPr>
             </a:pPr>
             <a:r>
-              <a:t>• Regulatory Compliance: Audit state-level net metering, solar tax credits, and candidate data privacy regulations (GDPR).</a:t>
+              <a:t>• Regulatory Compliance: Audit state-level solar net metering policies and candidate data privacy compliance (GDPR).</a:t>
             </a:r>
           </a:p>
         </p:txBody>
@@ -4005,7 +4005,7 @@
         </p:nvSpPr>
         <p:spPr>
           <a:xfrm>
-            <a:off x="548640" y="5623560"/>
+            <a:off x="548640" y="5577840"/>
             <a:ext cx="11094415" cy="594360"/>
           </a:xfrm>
           <a:prstGeom prst="rect">
@@ -4048,7 +4048,7 @@
         </p:nvSpPr>
         <p:spPr>
           <a:xfrm>
-            <a:off x="548640" y="5623560"/>
+            <a:off x="548640" y="5577840"/>
             <a:ext cx="73152" cy="594360"/>
           </a:xfrm>
           <a:prstGeom prst="rect">
@@ -4091,7 +4091,7 @@
         </p:nvSpPr>
         <p:spPr>
           <a:xfrm>
-            <a:off x="731520" y="5669280"/>
+            <a:off x="731520" y="5623560"/>
             <a:ext cx="10698480" cy="502920"/>
           </a:xfrm>
           <a:prstGeom prst="rect">
@@ -4128,7 +4128,7 @@
         <p:spPr>
           <a:xfrm>
             <a:off x="548640" y="1508760"/>
-            <a:ext cx="3514953" cy="3931920"/>
+            <a:ext cx="3332073" cy="3931920"/>
           </a:xfrm>
           <a:prstGeom prst="roundRect">
             <a:avLst/>
@@ -4166,14 +4166,67 @@
       </p:sp>
       <p:sp>
         <p:nvSpPr>
-          <p:cNvPr id="10" name="TextBox 9"/>
+          <p:cNvPr id="10" name="Oval 9"/>
+          <p:cNvSpPr/>
+          <p:nvPr/>
+        </p:nvSpPr>
+        <p:spPr>
+          <a:xfrm>
+            <a:off x="1920240" y="1691640"/>
+            <a:ext cx="588873" cy="588873"/>
+          </a:xfrm>
+          <a:prstGeom prst="ellipse">
+            <a:avLst/>
+          </a:prstGeom>
+          <a:solidFill>
+            <a:srgbClr val="D60000"/>
+          </a:solidFill>
+          <a:ln>
+            <a:noFill/>
+          </a:ln>
+        </p:spPr>
+        <p:style>
+          <a:lnRef idx="1">
+            <a:schemeClr val="accent1"/>
+          </a:lnRef>
+          <a:fillRef idx="3">
+            <a:schemeClr val="accent1"/>
+          </a:fillRef>
+          <a:effectRef idx="2">
+            <a:schemeClr val="accent1"/>
+          </a:effectRef>
+          <a:fontRef idx="minor">
+            <a:schemeClr val="lt1"/>
+          </a:fontRef>
+        </p:style>
+        <p:txBody>
+          <a:bodyPr rtlCol="0" anchor="ctr"/>
+          <a:lstStyle/>
+          <a:p>
+            <a:pPr algn="ctr">
+              <a:defRPr sz="1300" b="1">
+                <a:solidFill>
+                  <a:srgbClr val="FFFFFF"/>
+                </a:solidFill>
+                <a:latin typeface="Outfit"/>
+              </a:defRPr>
+            </a:pPr>
+            <a:r>
+              <a:t>M1</a:t>
+            </a:r>
+          </a:p>
+        </p:txBody>
+      </p:sp>
+      <p:sp>
+        <p:nvSpPr>
+          <p:cNvPr id="11" name="TextBox 10"/>
           <p:cNvSpPr txBox="1"/>
           <p:nvPr/>
         </p:nvSpPr>
         <p:spPr>
           <a:xfrm>
-            <a:off x="685800" y="1600200"/>
-            <a:ext cx="3240633" cy="3749039"/>
+            <a:off x="685800" y="2377440"/>
+            <a:ext cx="3057753" cy="2926080"/>
           </a:xfrm>
           <a:prstGeom prst="rect">
             <a:avLst/>
@@ -4186,7 +4239,7 @@
           </a:bodyPr>
           <a:lstStyle/>
           <a:p>
-            <a:pPr>
+            <a:pPr algn="ctr">
               <a:spcAft>
                 <a:spcPts val="400"/>
               </a:spcAft>
@@ -4202,7 +4255,7 @@
             </a:r>
           </a:p>
           <a:p>
-            <a:pPr>
+            <a:pPr algn="ctr">
               <a:spcAft>
                 <a:spcPts val="1000"/>
               </a:spcAft>
@@ -4218,10 +4271,7 @@
             </a:r>
           </a:p>
           <a:p>
-            <a:pPr>
-              <a:spcAft>
-                <a:spcPts val="600"/>
-              </a:spcAft>
+            <a:pPr algn="ctr">
               <a:defRPr sz="950">
                 <a:solidFill>
                   <a:srgbClr val="1E293B"/>
@@ -4230,53 +4280,21 @@
               </a:defRPr>
             </a:pPr>
             <a:r>
-              <a:t>• Audit developer utilization rates.</a:t>
-            </a:r>
-          </a:p>
-          <a:p>
-            <a:pPr>
-              <a:spcAft>
-                <a:spcPts val="600"/>
-              </a:spcAft>
-              <a:defRPr sz="950">
-                <a:solidFill>
-                  <a:srgbClr val="1E293B"/>
-                </a:solidFill>
-                <a:latin typeface="Inter"/>
-              </a:defRPr>
-            </a:pPr>
-            <a:r>
-              <a:t>• Analyze Nature Grid margins.</a:t>
-            </a:r>
-          </a:p>
-          <a:p>
-            <a:pPr>
-              <a:spcAft>
-                <a:spcPts val="600"/>
-              </a:spcAft>
-              <a:defRPr sz="950">
-                <a:solidFill>
-                  <a:srgbClr val="1E293B"/>
-                </a:solidFill>
-                <a:latin typeface="Inter"/>
-              </a:defRPr>
-            </a:pPr>
-            <a:r>
-              <a:t>• Map Aequalis's client accounts for warm SaaS cross-sell opportunities.</a:t>
-            </a:r>
-          </a:p>
-        </p:txBody>
-      </p:sp>
-      <p:sp>
-        <p:nvSpPr>
-          <p:cNvPr id="11" name="Right Arrow 10"/>
+              <a:t>Audit JCS developer utilization rates, analyze Nature Grid C&amp;I solar project margins, and identify target Aequalis CRM cross-sell accounts.</a:t>
+            </a:r>
+          </a:p>
+        </p:txBody>
+      </p:sp>
+      <p:sp>
+        <p:nvSpPr>
+          <p:cNvPr id="12" name="Right Arrow 11"/>
           <p:cNvSpPr/>
           <p:nvPr/>
         </p:nvSpPr>
         <p:spPr>
           <a:xfrm>
-            <a:off x="4109313" y="3291840"/>
-            <a:ext cx="182880" cy="182880"/>
+            <a:off x="4017873" y="3291840"/>
+            <a:ext cx="274320" cy="182880"/>
           </a:xfrm>
           <a:prstGeom prst="rightArrow">
             <a:avLst/>
@@ -4312,14 +4330,14 @@
       </p:sp>
       <p:sp>
         <p:nvSpPr>
-          <p:cNvPr id="12" name="Rounded Rectangle 11"/>
+          <p:cNvPr id="13" name="Rounded Rectangle 12"/>
           <p:cNvSpPr/>
           <p:nvPr/>
         </p:nvSpPr>
         <p:spPr>
           <a:xfrm>
-            <a:off x="4337913" y="1508760"/>
-            <a:ext cx="3514953" cy="3931920"/>
+            <a:off x="4429353" y="1508760"/>
+            <a:ext cx="3332073" cy="3931920"/>
           </a:xfrm>
           <a:prstGeom prst="roundRect">
             <a:avLst/>
@@ -4357,14 +4375,67 @@
       </p:sp>
       <p:sp>
         <p:nvSpPr>
-          <p:cNvPr id="13" name="TextBox 12"/>
+          <p:cNvPr id="14" name="Oval 13"/>
+          <p:cNvSpPr/>
+          <p:nvPr/>
+        </p:nvSpPr>
+        <p:spPr>
+          <a:xfrm>
+            <a:off x="5800953" y="1691640"/>
+            <a:ext cx="588873" cy="588873"/>
+          </a:xfrm>
+          <a:prstGeom prst="ellipse">
+            <a:avLst/>
+          </a:prstGeom>
+          <a:solidFill>
+            <a:srgbClr val="0F2537"/>
+          </a:solidFill>
+          <a:ln>
+            <a:noFill/>
+          </a:ln>
+        </p:spPr>
+        <p:style>
+          <a:lnRef idx="1">
+            <a:schemeClr val="accent1"/>
+          </a:lnRef>
+          <a:fillRef idx="3">
+            <a:schemeClr val="accent1"/>
+          </a:fillRef>
+          <a:effectRef idx="2">
+            <a:schemeClr val="accent1"/>
+          </a:effectRef>
+          <a:fontRef idx="minor">
+            <a:schemeClr val="lt1"/>
+          </a:fontRef>
+        </p:style>
+        <p:txBody>
+          <a:bodyPr rtlCol="0" anchor="ctr"/>
+          <a:lstStyle/>
+          <a:p>
+            <a:pPr algn="ctr">
+              <a:defRPr sz="1300" b="1">
+                <a:solidFill>
+                  <a:srgbClr val="FFFFFF"/>
+                </a:solidFill>
+                <a:latin typeface="Outfit"/>
+              </a:defRPr>
+            </a:pPr>
+            <a:r>
+              <a:t>M2</a:t>
+            </a:r>
+          </a:p>
+        </p:txBody>
+      </p:sp>
+      <p:sp>
+        <p:nvSpPr>
+          <p:cNvPr id="15" name="TextBox 14"/>
           <p:cNvSpPr txBox="1"/>
           <p:nvPr/>
         </p:nvSpPr>
         <p:spPr>
           <a:xfrm>
-            <a:off x="4475073" y="1600200"/>
-            <a:ext cx="3240633" cy="3749039"/>
+            <a:off x="4566513" y="2377440"/>
+            <a:ext cx="3057753" cy="2926080"/>
           </a:xfrm>
           <a:prstGeom prst="rect">
             <a:avLst/>
@@ -4377,13 +4448,13 @@
           </a:bodyPr>
           <a:lstStyle/>
           <a:p>
-            <a:pPr>
+            <a:pPr algn="ctr">
               <a:spcAft>
                 <a:spcPts val="400"/>
               </a:spcAft>
               <a:defRPr sz="850" b="1">
                 <a:solidFill>
-                  <a:srgbClr val="0284C7"/>
+                  <a:srgbClr val="64748B"/>
                 </a:solidFill>
                 <a:latin typeface="Inter"/>
               </a:defRPr>
@@ -4393,7 +4464,7 @@
             </a:r>
           </a:p>
           <a:p>
-            <a:pPr>
+            <a:pPr algn="ctr">
               <a:spcAft>
                 <a:spcPts val="1000"/>
               </a:spcAft>
@@ -4409,10 +4480,7 @@
             </a:r>
           </a:p>
           <a:p>
-            <a:pPr>
-              <a:spcAft>
-                <a:spcPts val="600"/>
-              </a:spcAft>
+            <a:pPr algn="ctr">
               <a:defRPr sz="950">
                 <a:solidFill>
                   <a:srgbClr val="1E293B"/>
@@ -4421,53 +4489,21 @@
               </a:defRPr>
             </a:pPr>
             <a:r>
-              <a:t>• Score pipeline ideas using prioritized scorecard.</a:t>
-            </a:r>
-          </a:p>
-          <a:p>
-            <a:pPr>
-              <a:spcAft>
-                <a:spcPts val="600"/>
-              </a:spcAft>
-              <a:defRPr sz="950">
-                <a:solidFill>
-                  <a:srgbClr val="1E293B"/>
-                </a:solidFill>
-                <a:latin typeface="Inter"/>
-              </a:defRPr>
-            </a:pPr>
-            <a:r>
-              <a:t>• Build interactive B2B simulators to demonstrate solar &amp; staffing SaaS.</a:t>
-            </a:r>
-          </a:p>
-          <a:p>
-            <a:pPr>
-              <a:spcAft>
-                <a:spcPts val="600"/>
-              </a:spcAft>
-              <a:defRPr sz="950">
-                <a:solidFill>
-                  <a:srgbClr val="1E293B"/>
-                </a:solidFill>
-                <a:latin typeface="Inter"/>
-              </a:defRPr>
-            </a:pPr>
-            <a:r>
-              <a:t>• Draft API connector marketplace database schemas.</a:t>
-            </a:r>
-          </a:p>
-        </p:txBody>
-      </p:sp>
-      <p:sp>
-        <p:nvSpPr>
-          <p:cNvPr id="14" name="Right Arrow 13"/>
+              <a:t>Score pipeline ideas using prioritized scorecard. Build interactive B2B simulators to demonstrate solar &amp; staffing SaaS concepts to clients.</a:t>
+            </a:r>
+          </a:p>
+        </p:txBody>
+      </p:sp>
+      <p:sp>
+        <p:nvSpPr>
+          <p:cNvPr id="16" name="Right Arrow 15"/>
           <p:cNvSpPr/>
           <p:nvPr/>
         </p:nvSpPr>
         <p:spPr>
           <a:xfrm>
             <a:off x="7898586" y="3291840"/>
-            <a:ext cx="182880" cy="182880"/>
+            <a:ext cx="274320" cy="182880"/>
           </a:xfrm>
           <a:prstGeom prst="rightArrow">
             <a:avLst/>
@@ -4503,14 +4539,14 @@
       </p:sp>
       <p:sp>
         <p:nvSpPr>
-          <p:cNvPr id="15" name="Rounded Rectangle 14"/>
+          <p:cNvPr id="17" name="Rounded Rectangle 16"/>
           <p:cNvSpPr/>
           <p:nvPr/>
         </p:nvSpPr>
         <p:spPr>
           <a:xfrm>
-            <a:off x="8127186" y="1508760"/>
-            <a:ext cx="3514953" cy="3931920"/>
+            <a:off x="8310066" y="1508760"/>
+            <a:ext cx="3332073" cy="3931920"/>
           </a:xfrm>
           <a:prstGeom prst="roundRect">
             <a:avLst/>
@@ -4548,14 +4584,67 @@
       </p:sp>
       <p:sp>
         <p:nvSpPr>
-          <p:cNvPr id="16" name="TextBox 15"/>
+          <p:cNvPr id="18" name="Oval 17"/>
+          <p:cNvSpPr/>
+          <p:nvPr/>
+        </p:nvSpPr>
+        <p:spPr>
+          <a:xfrm>
+            <a:off x="9681666" y="1691640"/>
+            <a:ext cx="588873" cy="588873"/>
+          </a:xfrm>
+          <a:prstGeom prst="ellipse">
+            <a:avLst/>
+          </a:prstGeom>
+          <a:solidFill>
+            <a:srgbClr val="0284C7"/>
+          </a:solidFill>
+          <a:ln>
+            <a:noFill/>
+          </a:ln>
+        </p:spPr>
+        <p:style>
+          <a:lnRef idx="1">
+            <a:schemeClr val="accent1"/>
+          </a:lnRef>
+          <a:fillRef idx="3">
+            <a:schemeClr val="accent1"/>
+          </a:fillRef>
+          <a:effectRef idx="2">
+            <a:schemeClr val="accent1"/>
+          </a:effectRef>
+          <a:fontRef idx="minor">
+            <a:schemeClr val="lt1"/>
+          </a:fontRef>
+        </p:style>
+        <p:txBody>
+          <a:bodyPr rtlCol="0" anchor="ctr"/>
+          <a:lstStyle/>
+          <a:p>
+            <a:pPr algn="ctr">
+              <a:defRPr sz="1300" b="1">
+                <a:solidFill>
+                  <a:srgbClr val="FFFFFF"/>
+                </a:solidFill>
+                <a:latin typeface="Outfit"/>
+              </a:defRPr>
+            </a:pPr>
+            <a:r>
+              <a:t>M3</a:t>
+            </a:r>
+          </a:p>
+        </p:txBody>
+      </p:sp>
+      <p:sp>
+        <p:nvSpPr>
+          <p:cNvPr id="19" name="TextBox 18"/>
           <p:cNvSpPr txBox="1"/>
           <p:nvPr/>
         </p:nvSpPr>
         <p:spPr>
           <a:xfrm>
-            <a:off x="8264346" y="1600200"/>
-            <a:ext cx="3240633" cy="3749039"/>
+            <a:off x="8447226" y="2377440"/>
+            <a:ext cx="3057753" cy="2926080"/>
           </a:xfrm>
           <a:prstGeom prst="rect">
             <a:avLst/>
@@ -4568,13 +4657,13 @@
           </a:bodyPr>
           <a:lstStyle/>
           <a:p>
-            <a:pPr>
+            <a:pPr algn="ctr">
               <a:spcAft>
                 <a:spcPts val="400"/>
               </a:spcAft>
               <a:defRPr sz="850" b="1">
                 <a:solidFill>
-                  <a:srgbClr val="0284C7"/>
+                  <a:srgbClr val="64748B"/>
                 </a:solidFill>
                 <a:latin typeface="Inter"/>
               </a:defRPr>
@@ -4584,7 +4673,7 @@
             </a:r>
           </a:p>
           <a:p>
-            <a:pPr>
+            <a:pPr algn="ctr">
               <a:spcAft>
                 <a:spcPts val="1000"/>
               </a:spcAft>
@@ -4596,14 +4685,11 @@
               </a:defRPr>
             </a:pPr>
             <a:r>
-              <a:t>Phase 3: Pilot &amp; Validate</a:t>
-            </a:r>
-          </a:p>
-          <a:p>
-            <a:pPr>
-              <a:spcAft>
-                <a:spcPts val="600"/>
-              </a:spcAft>
+              <a:t>Phase 3: Validate</a:t>
+            </a:r>
+          </a:p>
+          <a:p>
+            <a:pPr algn="ctr">
               <a:defRPr sz="950">
                 <a:solidFill>
                   <a:srgbClr val="1E293B"/>
@@ -4612,39 +4698,7 @@
               </a:defRPr>
             </a:pPr>
             <a:r>
-              <a:t>• Present simulators to 5 strategic B2B clients.</a:t>
-            </a:r>
-          </a:p>
-          <a:p>
-            <a:pPr>
-              <a:spcAft>
-                <a:spcPts val="600"/>
-              </a:spcAft>
-              <a:defRPr sz="950">
-                <a:solidFill>
-                  <a:srgbClr val="1E293B"/>
-                </a:solidFill>
-                <a:latin typeface="Inter"/>
-              </a:defRPr>
-            </a:pPr>
-            <a:r>
-              <a:t>• Collect feedback, define subscription pricing models.</a:t>
-            </a:r>
-          </a:p>
-          <a:p>
-            <a:pPr>
-              <a:spcAft>
-                <a:spcPts val="600"/>
-              </a:spcAft>
-              <a:defRPr sz="950">
-                <a:solidFill>
-                  <a:srgbClr val="1E293B"/>
-                </a:solidFill>
-                <a:latin typeface="Inter"/>
-              </a:defRPr>
-            </a:pPr>
-            <a:r>
-              <a:t>• Secure early pilot letters of intent (LOI) to validate demand.</a:t>
+              <a:t>Present simulators to 5 target clients. Collect feedback, define subscription pricing models, and acquire early pilot commitments.</a:t>
             </a:r>
           </a:p>
         </p:txBody>
@@ -4826,7 +4880,7 @@
         </p:nvSpPr>
         <p:spPr>
           <a:xfrm>
-            <a:off x="548640" y="5623560"/>
+            <a:off x="548640" y="5577840"/>
             <a:ext cx="11094415" cy="594360"/>
           </a:xfrm>
           <a:prstGeom prst="rect">
@@ -4869,7 +4923,7 @@
         </p:nvSpPr>
         <p:spPr>
           <a:xfrm>
-            <a:off x="548640" y="5623560"/>
+            <a:off x="548640" y="5577840"/>
             <a:ext cx="73152" cy="594360"/>
           </a:xfrm>
           <a:prstGeom prst="rect">
@@ -4912,7 +4966,7 @@
         </p:nvSpPr>
         <p:spPr>
           <a:xfrm>
-            <a:off x="731520" y="5669280"/>
+            <a:off x="731520" y="5623560"/>
             <a:ext cx="10698480" cy="502920"/>
           </a:xfrm>
           <a:prstGeom prst="rect">
@@ -5007,9 +5061,9 @@
           </a:bodyPr>
           <a:lstStyle/>
           <a:p>
-            <a:pPr>
+            <a:pPr algn="ctr">
               <a:spcAft>
-                <a:spcPts val="400"/>
+                <a:spcPts val="800"/>
               </a:spcAft>
               <a:defRPr sz="850" b="1">
                 <a:solidFill>
@@ -5023,26 +5077,36 @@
             </a:r>
           </a:p>
           <a:p>
-            <a:pPr>
+            <a:pPr algn="ctr">
+              <a:defRPr sz="2800" b="1">
+                <a:solidFill>
+                  <a:srgbClr val="0F2537"/>
+                </a:solidFill>
+                <a:latin typeface="Outfit"/>
+              </a:defRPr>
+            </a:pPr>
+            <a:r>
+              <a:t>ROIC &amp; Margin</a:t>
+            </a:r>
+          </a:p>
+          <a:p>
+            <a:pPr algn="ctr">
               <a:spcAft>
-                <a:spcPts val="1000"/>
+                <a:spcPts val="1400"/>
               </a:spcAft>
-              <a:defRPr sz="1300" b="1">
-                <a:solidFill>
-                  <a:srgbClr val="0F2537"/>
-                </a:solidFill>
-                <a:latin typeface="Outfit"/>
-              </a:defRPr>
-            </a:pPr>
-            <a:r>
-              <a:t>Group Level Metrics</a:t>
-            </a:r>
-          </a:p>
-          <a:p>
-            <a:pPr>
-              <a:spcAft>
-                <a:spcPts val="600"/>
-              </a:spcAft>
+              <a:defRPr sz="900" b="1">
+                <a:solidFill>
+                  <a:srgbClr val="64748B"/>
+                </a:solidFill>
+                <a:latin typeface="Inter"/>
+              </a:defRPr>
+            </a:pPr>
+            <a:r>
+              <a:t>Group Efficiency</a:t>
+            </a:r>
+          </a:p>
+          <a:p>
+            <a:pPr algn="ctr">
               <a:defRPr sz="950">
                 <a:solidFill>
                   <a:srgbClr val="1E293B"/>
@@ -5051,39 +5115,7 @@
               </a:defRPr>
             </a:pPr>
             <a:r>
-              <a:t>• Group-wide EBITDA margin expansion.</a:t>
-            </a:r>
-          </a:p>
-          <a:p>
-            <a:pPr>
-              <a:spcAft>
-                <a:spcPts val="600"/>
-              </a:spcAft>
-              <a:defRPr sz="950">
-                <a:solidFill>
-                  <a:srgbClr val="1E293B"/>
-                </a:solidFill>
-                <a:latin typeface="Inter"/>
-              </a:defRPr>
-            </a:pPr>
-            <a:r>
-              <a:t>• Group Return on Invested Capital (ROIC).</a:t>
-            </a:r>
-          </a:p>
-          <a:p>
-            <a:pPr>
-              <a:spcAft>
-                <a:spcPts val="600"/>
-              </a:spcAft>
-              <a:defRPr sz="950">
-                <a:solidFill>
-                  <a:srgbClr val="1E293B"/>
-                </a:solidFill>
-                <a:latin typeface="Inter"/>
-              </a:defRPr>
-            </a:pPr>
-            <a:r>
-              <a:t>• Software engineer resource utilization rates.</a:t>
+              <a:t>Track overall Group Return on Invested Capital, group-wide EBITDA margin expansion, and software developer utilization rates.</a:t>
             </a:r>
           </a:p>
         </p:txBody>
@@ -5155,42 +5187,52 @@
           </a:bodyPr>
           <a:lstStyle/>
           <a:p>
-            <a:pPr>
+            <a:pPr algn="ctr">
               <a:spcAft>
-                <a:spcPts val="400"/>
+                <a:spcPts val="800"/>
               </a:spcAft>
               <a:defRPr sz="850" b="1">
                 <a:solidFill>
+                  <a:srgbClr val="64748B"/>
+                </a:solidFill>
+                <a:latin typeface="Inter"/>
+              </a:defRPr>
+            </a:pPr>
+            <a:r>
+              <a:t>[UNIT ECONOMICS]</a:t>
+            </a:r>
+          </a:p>
+          <a:p>
+            <a:pPr algn="ctr">
+              <a:defRPr sz="2800" b="1">
+                <a:solidFill>
                   <a:srgbClr val="0284C7"/>
                 </a:solidFill>
+                <a:latin typeface="Outfit"/>
+              </a:defRPr>
+            </a:pPr>
+            <a:r>
+              <a:t>&gt; 3.0x</a:t>
+            </a:r>
+          </a:p>
+          <a:p>
+            <a:pPr algn="ctr">
+              <a:spcAft>
+                <a:spcPts val="1400"/>
+              </a:spcAft>
+              <a:defRPr sz="900" b="1">
+                <a:solidFill>
+                  <a:srgbClr val="64748B"/>
+                </a:solidFill>
                 <a:latin typeface="Inter"/>
               </a:defRPr>
             </a:pPr>
             <a:r>
-              <a:t>[UNIT ECONOMICS]</a:t>
-            </a:r>
-          </a:p>
-          <a:p>
-            <a:pPr>
-              <a:spcAft>
-                <a:spcPts val="1000"/>
-              </a:spcAft>
-              <a:defRPr sz="1300" b="1">
-                <a:solidFill>
-                  <a:srgbClr val="0F2537"/>
-                </a:solidFill>
-                <a:latin typeface="Outfit"/>
-              </a:defRPr>
-            </a:pPr>
-            <a:r>
-              <a:t>Commercial Viability</a:t>
-            </a:r>
-          </a:p>
-          <a:p>
-            <a:pPr>
-              <a:spcAft>
-                <a:spcPts val="600"/>
-              </a:spcAft>
+              <a:t>LTV : CAC Target</a:t>
+            </a:r>
+          </a:p>
+          <a:p>
+            <a:pPr algn="ctr">
               <a:defRPr sz="950">
                 <a:solidFill>
                   <a:srgbClr val="1E293B"/>
@@ -5199,39 +5241,7 @@
               </a:defRPr>
             </a:pPr>
             <a:r>
-              <a:t>• Customer Lifetime Value to CAC ratio (LTV:CAC) &gt; 3.0x.</a:t>
-            </a:r>
-          </a:p>
-          <a:p>
-            <a:pPr>
-              <a:spcAft>
-                <a:spcPts val="600"/>
-              </a:spcAft>
-              <a:defRPr sz="950">
-                <a:solidFill>
-                  <a:srgbClr val="1E293B"/>
-                </a:solidFill>
-                <a:latin typeface="Inter"/>
-              </a:defRPr>
-            </a:pPr>
-            <a:r>
-              <a:t>• Cash payback cycle under 12 months.</a:t>
-            </a:r>
-          </a:p>
-          <a:p>
-            <a:pPr>
-              <a:spcAft>
-                <a:spcPts val="600"/>
-              </a:spcAft>
-              <a:defRPr sz="950">
-                <a:solidFill>
-                  <a:srgbClr val="1E293B"/>
-                </a:solidFill>
-                <a:latin typeface="Inter"/>
-              </a:defRPr>
-            </a:pPr>
-            <a:r>
-              <a:t>• Subscription churn rate under 1.5% per month.</a:t>
+              <a:t>Enforce Customer Lifetime Value to CAC ratios above 3x, and cash payback cycles under 12 months for commercial software pilots.</a:t>
             </a:r>
           </a:p>
         </p:txBody>
@@ -5303,9 +5313,9 @@
           </a:bodyPr>
           <a:lstStyle/>
           <a:p>
-            <a:pPr>
+            <a:pPr algn="ctr">
               <a:spcAft>
-                <a:spcPts val="400"/>
+                <a:spcPts val="800"/>
               </a:spcAft>
               <a:defRPr sz="850" b="1">
                 <a:solidFill>
@@ -5319,26 +5329,36 @@
             </a:r>
           </a:p>
           <a:p>
-            <a:pPr>
+            <a:pPr algn="ctr">
+              <a:defRPr sz="2800" b="1">
+                <a:solidFill>
+                  <a:srgbClr val="D60000"/>
+                </a:solidFill>
+                <a:latin typeface="Outfit"/>
+              </a:defRPr>
+            </a:pPr>
+            <a:r>
+              <a:t>Day 60</a:t>
+            </a:r>
+          </a:p>
+          <a:p>
+            <a:pPr algn="ctr">
               <a:spcAft>
-                <a:spcPts val="1000"/>
+                <a:spcPts val="1400"/>
               </a:spcAft>
-              <a:defRPr sz="1300" b="1">
-                <a:solidFill>
-                  <a:srgbClr val="0F2537"/>
-                </a:solidFill>
-                <a:latin typeface="Outfit"/>
-              </a:defRPr>
-            </a:pPr>
-            <a:r>
-              <a:t>Fail-Fast Rules</a:t>
-            </a:r>
-          </a:p>
-          <a:p>
-            <a:pPr>
-              <a:spcAft>
-                <a:spcPts val="600"/>
-              </a:spcAft>
+              <a:defRPr sz="900" b="1">
+                <a:solidFill>
+                  <a:srgbClr val="64748B"/>
+                </a:solidFill>
+                <a:latin typeface="Inter"/>
+              </a:defRPr>
+            </a:pPr>
+            <a:r>
+              <a:t>Kill / Pivot Gate</a:t>
+            </a:r>
+          </a:p>
+          <a:p>
+            <a:pPr algn="ctr">
               <a:defRPr sz="950">
                 <a:solidFill>
                   <a:srgbClr val="1E293B"/>
@@ -5347,39 +5367,7 @@
               </a:defRPr>
             </a:pPr>
             <a:r>
-              <a:t>• Enforce strict 60-day development milestones.</a:t>
-            </a:r>
-          </a:p>
-          <a:p>
-            <a:pPr>
-              <a:spcAft>
-                <a:spcPts val="600"/>
-              </a:spcAft>
-              <a:defRPr sz="950">
-                <a:solidFill>
-                  <a:srgbClr val="1E293B"/>
-                </a:solidFill>
-                <a:latin typeface="Inter"/>
-              </a:defRPr>
-            </a:pPr>
-            <a:r>
-              <a:t>• Automatically terminate any MVP that does not secure at least 2 paid pilot commitments in 60 days.</a:t>
-            </a:r>
-          </a:p>
-          <a:p>
-            <a:pPr>
-              <a:spcAft>
-                <a:spcPts val="600"/>
-              </a:spcAft>
-              <a:defRPr sz="950">
-                <a:solidFill>
-                  <a:srgbClr val="1E293B"/>
-                </a:solidFill>
-                <a:latin typeface="Inter"/>
-              </a:defRPr>
-            </a:pPr>
-            <a:r>
-              <a:t>• Target &gt; 70% early rejection rate at the design gate.</a:t>
+              <a:t>Automatically terminate any B2B MVP project that does not secure at least 2 paid client pilot signups within 60 days of launch.</a:t>
             </a:r>
           </a:p>
         </p:txBody>
@@ -5561,7 +5549,7 @@
         </p:nvSpPr>
         <p:spPr>
           <a:xfrm>
-            <a:off x="548640" y="5623560"/>
+            <a:off x="548640" y="5577840"/>
             <a:ext cx="11094415" cy="594360"/>
           </a:xfrm>
           <a:prstGeom prst="rect">
@@ -5604,7 +5592,7 @@
         </p:nvSpPr>
         <p:spPr>
           <a:xfrm>
-            <a:off x="548640" y="5623560"/>
+            <a:off x="548640" y="5577840"/>
             <a:ext cx="73152" cy="594360"/>
           </a:xfrm>
           <a:prstGeom prst="rect">
@@ -5647,7 +5635,7 @@
         </p:nvSpPr>
         <p:spPr>
           <a:xfrm>
-            <a:off x="731520" y="5669280"/>
+            <a:off x="731520" y="5623560"/>
             <a:ext cx="10698480" cy="502920"/>
           </a:xfrm>
           <a:prstGeom prst="rect">
@@ -6132,7 +6120,7 @@
         </p:nvSpPr>
         <p:spPr>
           <a:xfrm>
-            <a:off x="548640" y="5623560"/>
+            <a:off x="548640" y="5577840"/>
             <a:ext cx="11094415" cy="594360"/>
           </a:xfrm>
           <a:prstGeom prst="rect">
@@ -6175,7 +6163,7 @@
         </p:nvSpPr>
         <p:spPr>
           <a:xfrm>
-            <a:off x="548640" y="5623560"/>
+            <a:off x="548640" y="5577840"/>
             <a:ext cx="73152" cy="594360"/>
           </a:xfrm>
           <a:prstGeom prst="rect">
@@ -6218,7 +6206,7 @@
         </p:nvSpPr>
         <p:spPr>
           <a:xfrm>
-            <a:off x="731520" y="5669280"/>
+            <a:off x="731520" y="5623560"/>
             <a:ext cx="10698480" cy="502920"/>
           </a:xfrm>
           <a:prstGeom prst="rect">
@@ -6313,23 +6301,36 @@
           </a:bodyPr>
           <a:lstStyle/>
           <a:p>
-            <a:pPr>
+            <a:pPr algn="ctr">
               <a:spcAft>
-                <a:spcPts val="400"/>
+                <a:spcPts val="800"/>
               </a:spcAft>
               <a:defRPr sz="850" b="1">
                 <a:solidFill>
+                  <a:srgbClr val="0284C7"/>
+                </a:solidFill>
+                <a:latin typeface="Inter"/>
+              </a:defRPr>
+            </a:pPr>
+            <a:r>
+              <a:t>[JCS (TECHNOLOGY)]</a:t>
+            </a:r>
+          </a:p>
+          <a:p>
+            <a:pPr algn="ctr">
+              <a:defRPr sz="800" b="1">
+                <a:solidFill>
                   <a:srgbClr val="64748B"/>
                 </a:solidFill>
                 <a:latin typeface="Inter"/>
               </a:defRPr>
             </a:pPr>
             <a:r>
-              <a:t>[JCS (TECHNOLOGY)]</a:t>
-            </a:r>
-          </a:p>
-          <a:p>
-            <a:pPr>
+              <a:t>CORE SERVICES</a:t>
+            </a:r>
+          </a:p>
+          <a:p>
+            <a:pPr algn="ctr">
               <a:spcAft>
                 <a:spcPts val="1000"/>
               </a:spcAft>
@@ -6341,14 +6342,56 @@
               </a:defRPr>
             </a:pPr>
             <a:r>
-              <a:t>Core: Software Consulting</a:t>
-            </a:r>
-          </a:p>
-          <a:p>
-            <a:pPr>
+              <a:t>Software Consulting</a:t>
+            </a:r>
+          </a:p>
+          <a:p>
+            <a:pPr algn="ctr">
+              <a:defRPr sz="800" b="1">
+                <a:solidFill>
+                  <a:srgbClr val="D60000"/>
+                </a:solidFill>
+                <a:latin typeface="Inter"/>
+              </a:defRPr>
+            </a:pPr>
+            <a:r>
+              <a:t>PIVOT ADJACENCY</a:t>
+            </a:r>
+          </a:p>
+          <a:p>
+            <a:pPr algn="ctr">
               <a:spcAft>
-                <a:spcPts val="600"/>
+                <a:spcPts val="800"/>
               </a:spcAft>
+              <a:defRPr sz="1600" b="1">
+                <a:solidFill>
+                  <a:srgbClr val="D60000"/>
+                </a:solidFill>
+                <a:latin typeface="Outfit"/>
+              </a:defRPr>
+            </a:pPr>
+            <a:r>
+              <a:t>▼</a:t>
+            </a:r>
+          </a:p>
+          <a:p>
+            <a:pPr algn="ctr">
+              <a:spcAft>
+                <a:spcPts val="400"/>
+              </a:spcAft>
+              <a:defRPr sz="1300" b="1">
+                <a:solidFill>
+                  <a:srgbClr val="0284C7"/>
+                </a:solidFill>
+                <a:latin typeface="Outfit"/>
+              </a:defRPr>
+            </a:pPr>
+            <a:r>
+              <a:t>Managed Service Retainers</a:t>
+            </a:r>
+          </a:p>
+          <a:p>
+            <a:pPr algn="ctr">
               <a:defRPr sz="950">
                 <a:solidFill>
                   <a:srgbClr val="1E293B"/>
@@ -6357,23 +6400,7 @@
               </a:defRPr>
             </a:pPr>
             <a:r>
-              <a:t>• Bespoke application dev and digital support.</a:t>
-            </a:r>
-          </a:p>
-          <a:p>
-            <a:pPr>
-              <a:spcAft>
-                <a:spcPts val="600"/>
-              </a:spcAft>
-              <a:defRPr sz="950">
-                <a:solidFill>
-                  <a:srgbClr val="1E293B"/>
-                </a:solidFill>
-                <a:latin typeface="Inter"/>
-              </a:defRPr>
-            </a:pPr>
-            <a:r>
-              <a:t>• Adjacency: Move from custom contracts to international managed service retainers to secure stable monthly software revenue.</a:t>
+              <a:t>Pivot bespoke developer project contracts to recurring monthly managed service fees.</a:t>
             </a:r>
           </a:p>
         </p:txBody>
@@ -6445,9 +6472,9 @@
           </a:bodyPr>
           <a:lstStyle/>
           <a:p>
-            <a:pPr>
+            <a:pPr algn="ctr">
               <a:spcAft>
-                <a:spcPts val="400"/>
+                <a:spcPts val="800"/>
               </a:spcAft>
               <a:defRPr sz="850" b="1">
                 <a:solidFill>
@@ -6461,7 +6488,20 @@
             </a:r>
           </a:p>
           <a:p>
-            <a:pPr>
+            <a:pPr algn="ctr">
+              <a:defRPr sz="800" b="1">
+                <a:solidFill>
+                  <a:srgbClr val="64748B"/>
+                </a:solidFill>
+                <a:latin typeface="Inter"/>
+              </a:defRPr>
+            </a:pPr>
+            <a:r>
+              <a:t>CORE SERVICES</a:t>
+            </a:r>
+          </a:p>
+          <a:p>
+            <a:pPr algn="ctr">
               <a:spcAft>
                 <a:spcPts val="1000"/>
               </a:spcAft>
@@ -6473,14 +6513,56 @@
               </a:defRPr>
             </a:pPr>
             <a:r>
-              <a:t>Core: Residential Solar</a:t>
-            </a:r>
-          </a:p>
-          <a:p>
-            <a:pPr>
+              <a:t>Residential Solar</a:t>
+            </a:r>
+          </a:p>
+          <a:p>
+            <a:pPr algn="ctr">
+              <a:defRPr sz="800" b="1">
+                <a:solidFill>
+                  <a:srgbClr val="D60000"/>
+                </a:solidFill>
+                <a:latin typeface="Inter"/>
+              </a:defRPr>
+            </a:pPr>
+            <a:r>
+              <a:t>PIVOT ADJACENCY</a:t>
+            </a:r>
+          </a:p>
+          <a:p>
+            <a:pPr algn="ctr">
               <a:spcAft>
-                <a:spcPts val="600"/>
+                <a:spcPts val="800"/>
               </a:spcAft>
+              <a:defRPr sz="1600" b="1">
+                <a:solidFill>
+                  <a:srgbClr val="D60000"/>
+                </a:solidFill>
+                <a:latin typeface="Outfit"/>
+              </a:defRPr>
+            </a:pPr>
+            <a:r>
+              <a:t>▼</a:t>
+            </a:r>
+          </a:p>
+          <a:p>
+            <a:pPr algn="ctr">
+              <a:spcAft>
+                <a:spcPts val="400"/>
+              </a:spcAft>
+              <a:defRPr sz="1300" b="1">
+                <a:solidFill>
+                  <a:srgbClr val="0284C7"/>
+                </a:solidFill>
+                <a:latin typeface="Outfit"/>
+              </a:defRPr>
+            </a:pPr>
+            <a:r>
+              <a:t>C&amp;I Projects + O&amp;M</a:t>
+            </a:r>
+          </a:p>
+          <a:p>
+            <a:pPr algn="ctr">
               <a:defRPr sz="950">
                 <a:solidFill>
                   <a:srgbClr val="1E293B"/>
@@ -6489,23 +6571,7 @@
               </a:defRPr>
             </a:pPr>
             <a:r>
-              <a:t>• Residential panel installs and setups.</a:t>
-            </a:r>
-          </a:p>
-          <a:p>
-            <a:pPr>
-              <a:spcAft>
-                <a:spcPts val="600"/>
-              </a:spcAft>
-              <a:defRPr sz="950">
-                <a:solidFill>
-                  <a:srgbClr val="1E293B"/>
-                </a:solidFill>
-                <a:latin typeface="Inter"/>
-              </a:defRPr>
-            </a:pPr>
-            <a:r>
-              <a:t>• Adjacency: Shift focus to Commercial &amp; Industrial (C&amp;I) installations and multi-year Operations &amp; Maintenance (O&amp;M) service contracts.</a:t>
+              <a:t>Pivot residential setups to Commercial solar contracts bundled with active telemetry monitoring retainers.</a:t>
             </a:r>
           </a:p>
         </p:txBody>
@@ -6577,9 +6643,9 @@
           </a:bodyPr>
           <a:lstStyle/>
           <a:p>
-            <a:pPr>
+            <a:pPr algn="ctr">
               <a:spcAft>
-                <a:spcPts val="400"/>
+                <a:spcPts val="800"/>
               </a:spcAft>
               <a:defRPr sz="850" b="1">
                 <a:solidFill>
@@ -6593,7 +6659,20 @@
             </a:r>
           </a:p>
           <a:p>
-            <a:pPr>
+            <a:pPr algn="ctr">
+              <a:defRPr sz="800" b="1">
+                <a:solidFill>
+                  <a:srgbClr val="64748B"/>
+                </a:solidFill>
+                <a:latin typeface="Inter"/>
+              </a:defRPr>
+            </a:pPr>
+            <a:r>
+              <a:t>CORE SERVICES</a:t>
+            </a:r>
+          </a:p>
+          <a:p>
+            <a:pPr algn="ctr">
               <a:spcAft>
                 <a:spcPts val="1000"/>
               </a:spcAft>
@@ -6605,14 +6684,56 @@
               </a:defRPr>
             </a:pPr>
             <a:r>
-              <a:t>Core: Executive Search</a:t>
-            </a:r>
-          </a:p>
-          <a:p>
-            <a:pPr>
+              <a:t>Executive Search</a:t>
+            </a:r>
+          </a:p>
+          <a:p>
+            <a:pPr algn="ctr">
+              <a:defRPr sz="800" b="1">
+                <a:solidFill>
+                  <a:srgbClr val="D60000"/>
+                </a:solidFill>
+                <a:latin typeface="Inter"/>
+              </a:defRPr>
+            </a:pPr>
+            <a:r>
+              <a:t>PIVOT ADJACENCY</a:t>
+            </a:r>
+          </a:p>
+          <a:p>
+            <a:pPr algn="ctr">
               <a:spcAft>
-                <a:spcPts val="600"/>
+                <a:spcPts val="800"/>
               </a:spcAft>
+              <a:defRPr sz="1600" b="1">
+                <a:solidFill>
+                  <a:srgbClr val="D60000"/>
+                </a:solidFill>
+                <a:latin typeface="Outfit"/>
+              </a:defRPr>
+            </a:pPr>
+            <a:r>
+              <a:t>▼</a:t>
+            </a:r>
+          </a:p>
+          <a:p>
+            <a:pPr algn="ctr">
+              <a:spcAft>
+                <a:spcPts val="400"/>
+              </a:spcAft>
+              <a:defRPr sz="1300" b="1">
+                <a:solidFill>
+                  <a:srgbClr val="0284C7"/>
+                </a:solidFill>
+                <a:latin typeface="Outfit"/>
+              </a:defRPr>
+            </a:pPr>
+            <a:r>
+              <a:t>Contract Staffing Retainers</a:t>
+            </a:r>
+          </a:p>
+          <a:p>
+            <a:pPr algn="ctr">
               <a:defRPr sz="950">
                 <a:solidFill>
                   <a:srgbClr val="1E293B"/>
@@ -6621,23 +6742,7 @@
               </a:defRPr>
             </a:pPr>
             <a:r>
-              <a:t>• Transactional recruiter matching and bulk hiring.</a:t>
-            </a:r>
-          </a:p>
-          <a:p>
-            <a:pPr>
-              <a:spcAft>
-                <a:spcPts val="600"/>
-              </a:spcAft>
-              <a:defRPr sz="950">
-                <a:solidFill>
-                  <a:srgbClr val="1E293B"/>
-                </a:solidFill>
-                <a:latin typeface="Inter"/>
-              </a:defRPr>
-            </a:pPr>
-            <a:r>
-              <a:t>• Adjacency: Pivot manual search fees into predictable, high-margin contract staffing retainers.</a:t>
+              <a:t>Pivot manual candidate search commissions to recurring B2B IT staffing retainer contracts.</a:t>
             </a:r>
           </a:p>
         </p:txBody>
@@ -6819,7 +6924,7 @@
         </p:nvSpPr>
         <p:spPr>
           <a:xfrm>
-            <a:off x="548640" y="5623560"/>
+            <a:off x="548640" y="5577840"/>
             <a:ext cx="11094415" cy="594360"/>
           </a:xfrm>
           <a:prstGeom prst="rect">
@@ -6862,7 +6967,7 @@
         </p:nvSpPr>
         <p:spPr>
           <a:xfrm>
-            <a:off x="548640" y="5623560"/>
+            <a:off x="548640" y="5577840"/>
             <a:ext cx="73152" cy="594360"/>
           </a:xfrm>
           <a:prstGeom prst="rect">
@@ -6905,7 +7010,7 @@
         </p:nvSpPr>
         <p:spPr>
           <a:xfrm>
-            <a:off x="731520" y="5669280"/>
+            <a:off x="731520" y="5623560"/>
             <a:ext cx="10698480" cy="502920"/>
           </a:xfrm>
           <a:prstGeom prst="rect">
@@ -7890,14 +7995,85 @@
       </p:sp>
       <p:sp>
         <p:nvSpPr>
-          <p:cNvPr id="11" name="TextBox 10"/>
+          <p:cNvPr id="11" name="Rectangle 10"/>
+          <p:cNvSpPr/>
+          <p:nvPr/>
+        </p:nvSpPr>
+        <p:spPr>
+          <a:xfrm>
+            <a:off x="8046720" y="1691640"/>
+            <a:ext cx="3139135" cy="1280160"/>
+          </a:xfrm>
+          <a:prstGeom prst="rect">
+            <a:avLst/>
+          </a:prstGeom>
+          <a:solidFill>
+            <a:srgbClr val="F8FAFC"/>
+          </a:solidFill>
+          <a:ln>
+            <a:solidFill>
+              <a:srgbClr val="CBD5E1"/>
+            </a:solidFill>
+          </a:ln>
+        </p:spPr>
+        <p:style>
+          <a:lnRef idx="1">
+            <a:schemeClr val="accent1"/>
+          </a:lnRef>
+          <a:fillRef idx="3">
+            <a:schemeClr val="accent1"/>
+          </a:fillRef>
+          <a:effectRef idx="2">
+            <a:schemeClr val="accent1"/>
+          </a:effectRef>
+          <a:fontRef idx="minor">
+            <a:schemeClr val="lt1"/>
+          </a:fontRef>
+        </p:style>
+        <p:txBody>
+          <a:bodyPr rtlCol="0" anchor="ctr" wrap="square"/>
+          <a:lstStyle/>
+          <a:p>
+            <a:pPr algn="ctr">
+              <a:defRPr sz="3600" b="1">
+                <a:solidFill>
+                  <a:srgbClr val="D60000"/>
+                </a:solidFill>
+                <a:latin typeface="Outfit"/>
+              </a:defRPr>
+            </a:pPr>
+            <a:r>
+              <a:t>65 / 100</a:t>
+            </a:r>
+          </a:p>
+          <a:p>
+            <a:pPr algn="ctr">
+              <a:spcBef>
+                <a:spcPts val="400"/>
+              </a:spcBef>
+              <a:defRPr sz="900" b="1">
+                <a:solidFill>
+                  <a:srgbClr val="64748B"/>
+                </a:solidFill>
+                <a:latin typeface="Inter"/>
+              </a:defRPr>
+            </a:pPr>
+            <a:r>
+              <a:t>Minimum MVP Gate Score</a:t>
+            </a:r>
+          </a:p>
+        </p:txBody>
+      </p:sp>
+      <p:sp>
+        <p:nvSpPr>
+          <p:cNvPr id="12" name="TextBox 11"/>
           <p:cNvSpPr txBox="1"/>
           <p:nvPr/>
         </p:nvSpPr>
         <p:spPr>
           <a:xfrm>
-            <a:off x="7726679" y="1600200"/>
-            <a:ext cx="3779215" cy="3749039"/>
+            <a:off x="7726679" y="3063240"/>
+            <a:ext cx="3779215" cy="2194560"/>
           </a:xfrm>
           <a:prstGeom prst="rect">
             <a:avLst/>
@@ -7909,42 +8085,26 @@
             <a:spAutoFit/>
           </a:bodyPr>
           <a:lstStyle/>
-          <a:p>
-            <a:pPr>
-              <a:spcAft>
-                <a:spcPts val="1200"/>
-              </a:spcAft>
-              <a:defRPr sz="1400" b="1">
-                <a:solidFill>
-                  <a:srgbClr val="0F2537"/>
-                </a:solidFill>
-                <a:latin typeface="Outfit"/>
-              </a:defRPr>
-            </a:pPr>
-            <a:r>
-              <a:t>Evaluation Protocol</a:t>
-            </a:r>
-          </a:p>
           <a:p>
             <a:pPr>
               <a:spcAft>
                 <a:spcPts val="1000"/>
               </a:spcAft>
-              <a:defRPr sz="950">
-                <a:solidFill>
-                  <a:srgbClr val="1E293B"/>
-                </a:solidFill>
-                <a:latin typeface="Inter"/>
-              </a:defRPr>
-            </a:pPr>
-            <a:r>
-              <a:t>• Opportunities are rated 1 to 10 across these 8 factors, resulting in a weighted score out of 100.</a:t>
+              <a:defRPr sz="1250" b="1">
+                <a:solidFill>
+                  <a:srgbClr val="0F2537"/>
+                </a:solidFill>
+                <a:latin typeface="Outfit"/>
+              </a:defRPr>
+            </a:pPr>
+            <a:r>
+              <a:t>Evaluation Protocol</a:t>
             </a:r>
           </a:p>
           <a:p>
             <a:pPr>
               <a:spcAft>
-                <a:spcPts val="1000"/>
+                <a:spcPts val="800"/>
               </a:spcAft>
               <a:defRPr sz="950">
                 <a:solidFill>
@@ -7954,13 +8114,29 @@
               </a:defRPr>
             </a:pPr>
             <a:r>
-              <a:t>• A threshold score of &gt;= 65/100 is required to allocate seed MVP validation funding.</a:t>
+              <a:t>• Opportunities are rated 1 to 10 across these 8 factors, resulting in a weighted score out of 100.</a:t>
             </a:r>
           </a:p>
           <a:p>
             <a:pPr>
               <a:spcAft>
-                <a:spcPts val="1000"/>
+                <a:spcPts val="800"/>
+              </a:spcAft>
+              <a:defRPr sz="950">
+                <a:solidFill>
+                  <a:srgbClr val="1E293B"/>
+                </a:solidFill>
+                <a:latin typeface="Inter"/>
+              </a:defRPr>
+            </a:pPr>
+            <a:r>
+              <a:t>• A threshold score of &gt;= 65/100 is required to allocate seed MVP validation funding.</a:t>
+            </a:r>
+          </a:p>
+          <a:p>
+            <a:pPr>
+              <a:spcAft>
+                <a:spcPts val="800"/>
               </a:spcAft>
               <a:defRPr sz="950">
                 <a:solidFill>
@@ -8152,7 +8328,7 @@
         </p:nvSpPr>
         <p:spPr>
           <a:xfrm>
-            <a:off x="548640" y="5623560"/>
+            <a:off x="548640" y="5577840"/>
             <a:ext cx="11094415" cy="594360"/>
           </a:xfrm>
           <a:prstGeom prst="rect">
@@ -8195,7 +8371,7 @@
         </p:nvSpPr>
         <p:spPr>
           <a:xfrm>
-            <a:off x="548640" y="5623560"/>
+            <a:off x="548640" y="5577840"/>
             <a:ext cx="73152" cy="594360"/>
           </a:xfrm>
           <a:prstGeom prst="rect">
@@ -8238,7 +8414,7 @@
         </p:nvSpPr>
         <p:spPr>
           <a:xfrm>
-            <a:off x="731520" y="5669280"/>
+            <a:off x="731520" y="5623560"/>
             <a:ext cx="10698480" cy="502920"/>
           </a:xfrm>
           <a:prstGeom prst="rect">
@@ -8830,14 +9006,85 @@
       </p:sp>
       <p:sp>
         <p:nvSpPr>
-          <p:cNvPr id="11" name="TextBox 10"/>
+          <p:cNvPr id="11" name="Rectangle 10"/>
+          <p:cNvSpPr/>
+          <p:nvPr/>
+        </p:nvSpPr>
+        <p:spPr>
+          <a:xfrm>
+            <a:off x="8046720" y="1691640"/>
+            <a:ext cx="3139135" cy="1280160"/>
+          </a:xfrm>
+          <a:prstGeom prst="rect">
+            <a:avLst/>
+          </a:prstGeom>
+          <a:solidFill>
+            <a:srgbClr val="F8FAFC"/>
+          </a:solidFill>
+          <a:ln>
+            <a:solidFill>
+              <a:srgbClr val="CBD5E1"/>
+            </a:solidFill>
+          </a:ln>
+        </p:spPr>
+        <p:style>
+          <a:lnRef idx="1">
+            <a:schemeClr val="accent1"/>
+          </a:lnRef>
+          <a:fillRef idx="3">
+            <a:schemeClr val="accent1"/>
+          </a:fillRef>
+          <a:effectRef idx="2">
+            <a:schemeClr val="accent1"/>
+          </a:effectRef>
+          <a:fontRef idx="minor">
+            <a:schemeClr val="lt1"/>
+          </a:fontRef>
+        </p:style>
+        <p:txBody>
+          <a:bodyPr rtlCol="0" anchor="ctr" wrap="square"/>
+          <a:lstStyle/>
+          <a:p>
+            <a:pPr algn="ctr">
+              <a:defRPr sz="3600" b="1">
+                <a:solidFill>
+                  <a:srgbClr val="D60000"/>
+                </a:solidFill>
+                <a:latin typeface="Outfit"/>
+              </a:defRPr>
+            </a:pPr>
+            <a:r>
+              <a:t>Rank 1: HR SaaS</a:t>
+            </a:r>
+          </a:p>
+          <a:p>
+            <a:pPr algn="ctr">
+              <a:spcBef>
+                <a:spcPts val="400"/>
+              </a:spcBef>
+              <a:defRPr sz="900" b="1">
+                <a:solidFill>
+                  <a:srgbClr val="64748B"/>
+                </a:solidFill>
+                <a:latin typeface="Inter"/>
+              </a:defRPr>
+            </a:pPr>
+            <a:r>
+              <a:t>Score: 84 / 100</a:t>
+            </a:r>
+          </a:p>
+        </p:txBody>
+      </p:sp>
+      <p:sp>
+        <p:nvSpPr>
+          <p:cNvPr id="12" name="TextBox 11"/>
           <p:cNvSpPr txBox="1"/>
           <p:nvPr/>
         </p:nvSpPr>
         <p:spPr>
           <a:xfrm>
-            <a:off x="7726679" y="1600200"/>
-            <a:ext cx="3779215" cy="3749039"/>
+            <a:off x="7726679" y="3063240"/>
+            <a:ext cx="3779215" cy="2194560"/>
           </a:xfrm>
           <a:prstGeom prst="rect">
             <a:avLst/>
@@ -8849,42 +9096,26 @@
             <a:spAutoFit/>
           </a:bodyPr>
           <a:lstStyle/>
-          <a:p>
-            <a:pPr>
-              <a:spcAft>
-                <a:spcPts val="1200"/>
-              </a:spcAft>
-              <a:defRPr sz="1400" b="1">
-                <a:solidFill>
-                  <a:srgbClr val="0F2537"/>
-                </a:solidFill>
-                <a:latin typeface="Outfit"/>
-              </a:defRPr>
-            </a:pPr>
-            <a:r>
-              <a:t>Strategic Synergy Logic</a:t>
-            </a:r>
-          </a:p>
           <a:p>
             <a:pPr>
               <a:spcAft>
                 <a:spcPts val="1000"/>
               </a:spcAft>
-              <a:defRPr sz="950">
-                <a:solidFill>
-                  <a:srgbClr val="1E293B"/>
-                </a:solidFill>
-                <a:latin typeface="Inter"/>
-              </a:defRPr>
-            </a:pPr>
-            <a:r>
-              <a:t>• Prioritize cross-business synergies where one unit's tech capability (JCS) scales another unit's distribution network (Aequalis, Nature Grid).</a:t>
+              <a:defRPr sz="1250" b="1">
+                <a:solidFill>
+                  <a:srgbClr val="0F2537"/>
+                </a:solidFill>
+                <a:latin typeface="Outfit"/>
+              </a:defRPr>
+            </a:pPr>
+            <a:r>
+              <a:t>Strategic Synergy Logic</a:t>
             </a:r>
           </a:p>
           <a:p>
             <a:pPr>
               <a:spcAft>
-                <a:spcPts val="1000"/>
+                <a:spcPts val="800"/>
               </a:spcAft>
               <a:defRPr sz="950">
                 <a:solidFill>
@@ -8894,13 +9125,29 @@
               </a:defRPr>
             </a:pPr>
             <a:r>
-              <a:t>• SaaS product models scale revenues exponentially without adding linear headcount or developer pools.</a:t>
+              <a:t>• Prioritize cross-business synergies where one unit's tech capability (JCS) scales another unit's distribution network (Aequalis, Nature Grid).</a:t>
             </a:r>
           </a:p>
           <a:p>
             <a:pPr>
               <a:spcAft>
-                <a:spcPts val="1000"/>
+                <a:spcPts val="800"/>
+              </a:spcAft>
+              <a:defRPr sz="950">
+                <a:solidFill>
+                  <a:srgbClr val="1E293B"/>
+                </a:solidFill>
+                <a:latin typeface="Inter"/>
+              </a:defRPr>
+            </a:pPr>
+            <a:r>
+              <a:t>• SaaS product models scale revenues exponentially without adding linear headcount or developer pools.</a:t>
+            </a:r>
+          </a:p>
+          <a:p>
+            <a:pPr>
+              <a:spcAft>
+                <a:spcPts val="800"/>
               </a:spcAft>
               <a:defRPr sz="950">
                 <a:solidFill>
@@ -9092,7 +9339,7 @@
         </p:nvSpPr>
         <p:spPr>
           <a:xfrm>
-            <a:off x="548640" y="5623560"/>
+            <a:off x="548640" y="5577840"/>
             <a:ext cx="11094415" cy="594360"/>
           </a:xfrm>
           <a:prstGeom prst="rect">
@@ -9135,7 +9382,7 @@
         </p:nvSpPr>
         <p:spPr>
           <a:xfrm>
-            <a:off x="548640" y="5623560"/>
+            <a:off x="548640" y="5577840"/>
             <a:ext cx="73152" cy="594360"/>
           </a:xfrm>
           <a:prstGeom prst="rect">
@@ -9178,7 +9425,7 @@
         </p:nvSpPr>
         <p:spPr>
           <a:xfrm>
-            <a:off x="731520" y="5669280"/>
+            <a:off x="731520" y="5623560"/>
             <a:ext cx="10698480" cy="502920"/>
           </a:xfrm>
           <a:prstGeom prst="rect">
@@ -9244,56 +9491,40 @@
           </a:fontRef>
         </p:style>
         <p:txBody>
-          <a:bodyPr rtlCol="0" anchor="ctr"/>
-          <a:lstStyle/>
-          <a:p>
-            <a:pPr algn="ctr"/>
-          </a:p>
-        </p:txBody>
-      </p:sp>
-      <p:sp>
-        <p:nvSpPr>
-          <p:cNvPr id="10" name="TextBox 9"/>
-          <p:cNvSpPr txBox="1"/>
-          <p:nvPr/>
-        </p:nvSpPr>
-        <p:spPr>
-          <a:xfrm>
-            <a:off x="685800" y="1600200"/>
-            <a:ext cx="3057753" cy="3749039"/>
-          </a:xfrm>
-          <a:prstGeom prst="rect">
-            <a:avLst/>
-          </a:prstGeom>
-          <a:noFill/>
-        </p:spPr>
-        <p:txBody>
-          <a:bodyPr wrap="square">
-            <a:spAutoFit/>
-          </a:bodyPr>
-          <a:lstStyle/>
-          <a:p>
-            <a:pPr>
+          <a:bodyPr rtlCol="0" anchor="ctr" wrap="square"/>
+          <a:lstStyle/>
+          <a:p>
+            <a:pPr algn="ctr">
+              <a:defRPr sz="3600" b="1">
+                <a:solidFill>
+                  <a:srgbClr val="D60000"/>
+                </a:solidFill>
+                <a:latin typeface="Outfit"/>
+              </a:defRPr>
+            </a:pPr>
+            <a:r>
+              <a:t>70%</a:t>
+            </a:r>
+          </a:p>
+          <a:p>
+            <a:pPr algn="ctr">
               <a:spcAft>
                 <a:spcPts val="1400"/>
               </a:spcAft>
-              <a:defRPr sz="1300" b="1">
-                <a:solidFill>
-                  <a:srgbClr val="0F2537"/>
-                </a:solidFill>
-                <a:latin typeface="Outfit"/>
-              </a:defRPr>
-            </a:pPr>
-            <a:r>
-              <a:t>1. Core Capability &amp; Pain</a:t>
-            </a:r>
-          </a:p>
-          <a:p>
-            <a:pPr>
-              <a:spcAft>
-                <a:spcPts val="1200"/>
-              </a:spcAft>
-              <a:defRPr sz="1050">
+              <a:defRPr sz="950" b="1">
+                <a:solidFill>
+                  <a:srgbClr val="64748B"/>
+                </a:solidFill>
+                <a:latin typeface="Inter"/>
+              </a:defRPr>
+            </a:pPr>
+            <a:r>
+              <a:t>Sourcing Time Saved</a:t>
+            </a:r>
+          </a:p>
+          <a:p>
+            <a:pPr algn="ctr">
+              <a:defRPr sz="950">
                 <a:solidFill>
                   <a:srgbClr val="1E293B"/>
                 </a:solidFill>
@@ -9301,20 +9532,20 @@
               </a:defRPr>
             </a:pPr>
             <a:r>
-              <a:t>Aequalis human recruiters manually read resumes, call candidates, and match profiles. Extremely slow, resource-heavy process. JCS has software engineers capable of automating screening pipelines.</a:t>
-            </a:r>
-          </a:p>
-        </p:txBody>
-      </p:sp>
-      <p:sp>
-        <p:nvSpPr>
-          <p:cNvPr id="11" name="Right Arrow 10"/>
+              <a:t>AI candidate screening parser scores resumes instantly, replacing human recruiter labor and accelerating hiring.</a:t>
+            </a:r>
+          </a:p>
+        </p:txBody>
+      </p:sp>
+      <p:sp>
+        <p:nvSpPr>
+          <p:cNvPr id="10" name="Right Arrow 9"/>
           <p:cNvSpPr/>
           <p:nvPr/>
         </p:nvSpPr>
         <p:spPr>
           <a:xfrm>
-            <a:off x="4017873" y="3291840"/>
+            <a:off x="4023360" y="3291840"/>
             <a:ext cx="274320" cy="182880"/>
           </a:xfrm>
           <a:prstGeom prst="rightArrow">
@@ -9351,13 +9582,13 @@
       </p:sp>
       <p:sp>
         <p:nvSpPr>
-          <p:cNvPr id="12" name="Rounded Rectangle 11"/>
+          <p:cNvPr id="11" name="Rounded Rectangle 10"/>
           <p:cNvSpPr/>
           <p:nvPr/>
         </p:nvSpPr>
         <p:spPr>
           <a:xfrm>
-            <a:off x="4429353" y="1508760"/>
+            <a:off x="4434840" y="1508760"/>
             <a:ext cx="3332073" cy="3931920"/>
           </a:xfrm>
           <a:prstGeom prst="roundRect">
@@ -9387,38 +9618,12 @@
           </a:fontRef>
         </p:style>
         <p:txBody>
-          <a:bodyPr rtlCol="0" anchor="ctr"/>
-          <a:lstStyle/>
-          <a:p>
-            <a:pPr algn="ctr"/>
-          </a:p>
-        </p:txBody>
-      </p:sp>
-      <p:sp>
-        <p:nvSpPr>
-          <p:cNvPr id="13" name="TextBox 12"/>
-          <p:cNvSpPr txBox="1"/>
-          <p:nvPr/>
-        </p:nvSpPr>
-        <p:spPr>
-          <a:xfrm>
-            <a:off x="4566513" y="1600200"/>
-            <a:ext cx="3057753" cy="3749039"/>
-          </a:xfrm>
-          <a:prstGeom prst="rect">
-            <a:avLst/>
-          </a:prstGeom>
-          <a:noFill/>
-        </p:spPr>
-        <p:txBody>
-          <a:bodyPr wrap="square">
-            <a:spAutoFit/>
-          </a:bodyPr>
-          <a:lstStyle/>
-          <a:p>
-            <a:pPr>
+          <a:bodyPr rtlCol="0" anchor="ctr" wrap="square"/>
+          <a:lstStyle/>
+          <a:p>
+            <a:pPr algn="ctr">
               <a:spcAft>
-                <a:spcPts val="1400"/>
+                <a:spcPts val="2000"/>
               </a:spcAft>
               <a:defRPr sz="1300" b="1">
                 <a:solidFill>
@@ -9428,15 +9633,12 @@
               </a:defRPr>
             </a:pPr>
             <a:r>
-              <a:t>2. The SaaS Solution</a:t>
-            </a:r>
-          </a:p>
-          <a:p>
-            <a:pPr>
-              <a:spcAft>
-                <a:spcPts val="1200"/>
-              </a:spcAft>
-              <a:defRPr sz="1050">
+              <a:t>JCS + Aequalis Synergy</a:t>
+            </a:r>
+          </a:p>
+          <a:p>
+            <a:pPr algn="ctr">
+              <a:defRPr sz="950">
                 <a:solidFill>
                   <a:srgbClr val="1E293B"/>
                 </a:solidFill>
@@ -9444,20 +9646,20 @@
               </a:defRPr>
             </a:pPr>
             <a:r>
-              <a:t>An automated applicant sourcing, screening, and matching platform. Integrates CV-matching algorithms to score candidates instantly. Aequalis cross-sells the platform to its corporate base.</a:t>
-            </a:r>
-          </a:p>
-        </p:txBody>
-      </p:sp>
-      <p:sp>
-        <p:nvSpPr>
-          <p:cNvPr id="14" name="Right Arrow 13"/>
+              <a:t>JCS engineers build the cloud matching algorithms. Aequalis acts as design partner and distributes directly to its database of corporate staffing clients, ensuring zero marketing CAC.</a:t>
+            </a:r>
+          </a:p>
+        </p:txBody>
+      </p:sp>
+      <p:sp>
+        <p:nvSpPr>
+          <p:cNvPr id="12" name="Right Arrow 11"/>
           <p:cNvSpPr/>
           <p:nvPr/>
         </p:nvSpPr>
         <p:spPr>
           <a:xfrm>
-            <a:off x="7898586" y="3291840"/>
+            <a:off x="7909560" y="3291840"/>
             <a:ext cx="274320" cy="182880"/>
           </a:xfrm>
           <a:prstGeom prst="rightArrow">
@@ -9494,13 +9696,13 @@
       </p:sp>
       <p:sp>
         <p:nvSpPr>
-          <p:cNvPr id="15" name="Rounded Rectangle 14"/>
+          <p:cNvPr id="13" name="Rounded Rectangle 12"/>
           <p:cNvSpPr/>
           <p:nvPr/>
         </p:nvSpPr>
         <p:spPr>
           <a:xfrm>
-            <a:off x="8310066" y="1508760"/>
+            <a:off x="8321040" y="1508760"/>
             <a:ext cx="3332073" cy="3931920"/>
           </a:xfrm>
           <a:prstGeom prst="roundRect">
@@ -9530,56 +9732,40 @@
           </a:fontRef>
         </p:style>
         <p:txBody>
-          <a:bodyPr rtlCol="0" anchor="ctr"/>
-          <a:lstStyle/>
-          <a:p>
-            <a:pPr algn="ctr"/>
-          </a:p>
-        </p:txBody>
-      </p:sp>
-      <p:sp>
-        <p:nvSpPr>
-          <p:cNvPr id="16" name="TextBox 15"/>
-          <p:cNvSpPr txBox="1"/>
-          <p:nvPr/>
-        </p:nvSpPr>
-        <p:spPr>
-          <a:xfrm>
-            <a:off x="8447226" y="1600200"/>
-            <a:ext cx="3057753" cy="3749039"/>
-          </a:xfrm>
-          <a:prstGeom prst="rect">
-            <a:avLst/>
-          </a:prstGeom>
-          <a:noFill/>
-        </p:spPr>
-        <p:txBody>
-          <a:bodyPr wrap="square">
-            <a:spAutoFit/>
-          </a:bodyPr>
-          <a:lstStyle/>
-          <a:p>
-            <a:pPr>
+          <a:bodyPr rtlCol="0" anchor="ctr" wrap="square"/>
+          <a:lstStyle/>
+          <a:p>
+            <a:pPr algn="ctr">
+              <a:defRPr sz="3600" b="1">
+                <a:solidFill>
+                  <a:srgbClr val="0284C7"/>
+                </a:solidFill>
+                <a:latin typeface="Outfit"/>
+              </a:defRPr>
+            </a:pPr>
+            <a:r>
+              <a:t>$2,000+</a:t>
+            </a:r>
+          </a:p>
+          <a:p>
+            <a:pPr algn="ctr">
               <a:spcAft>
                 <a:spcPts val="1400"/>
               </a:spcAft>
-              <a:defRPr sz="1300" b="1">
-                <a:solidFill>
-                  <a:srgbClr val="0284C7"/>
-                </a:solidFill>
-                <a:latin typeface="Outfit"/>
-              </a:defRPr>
-            </a:pPr>
-            <a:r>
-              <a:t>3. Target Economics</a:t>
-            </a:r>
-          </a:p>
-          <a:p>
-            <a:pPr>
-              <a:spcAft>
-                <a:spcPts val="1200"/>
-              </a:spcAft>
-              <a:defRPr sz="1050">
+              <a:defRPr sz="950" b="1">
+                <a:solidFill>
+                  <a:srgbClr val="64748B"/>
+                </a:solidFill>
+                <a:latin typeface="Inter"/>
+              </a:defRPr>
+            </a:pPr>
+            <a:r>
+              <a:t>Monthly SaaS ARPU</a:t>
+            </a:r>
+          </a:p>
+          <a:p>
+            <a:pPr algn="ctr">
+              <a:defRPr sz="950">
                 <a:solidFill>
                   <a:srgbClr val="1E293B"/>
                 </a:solidFill>
@@ -9587,7 +9773,7 @@
               </a:defRPr>
             </a:pPr>
             <a:r>
-              <a:t>Saves recruiters 70% of manual effort. Warm cross-selling eliminates marketing CAC. Standard monthly subscription contract captures $2,000+ monthly ARPU per enterprise client.</a:t>
+              <a:t>B2B subscription licensing captures high-margin recurring software revenues on top of traditional placement commissions.</a:t>
             </a:r>
           </a:p>
         </p:txBody>
@@ -9769,7 +9955,7 @@
         </p:nvSpPr>
         <p:spPr>
           <a:xfrm>
-            <a:off x="548640" y="5623560"/>
+            <a:off x="548640" y="5577840"/>
             <a:ext cx="11094415" cy="594360"/>
           </a:xfrm>
           <a:prstGeom prst="rect">
@@ -9812,7 +9998,7 @@
         </p:nvSpPr>
         <p:spPr>
           <a:xfrm>
-            <a:off x="548640" y="5623560"/>
+            <a:off x="548640" y="5577840"/>
             <a:ext cx="73152" cy="594360"/>
           </a:xfrm>
           <a:prstGeom prst="rect">
@@ -9855,7 +10041,7 @@
         </p:nvSpPr>
         <p:spPr>
           <a:xfrm>
-            <a:off x="731520" y="5669280"/>
+            <a:off x="731520" y="5623560"/>
             <a:ext cx="10698480" cy="502920"/>
           </a:xfrm>
           <a:prstGeom prst="rect">
@@ -9921,56 +10107,40 @@
           </a:fontRef>
         </p:style>
         <p:txBody>
-          <a:bodyPr rtlCol="0" anchor="ctr"/>
-          <a:lstStyle/>
-          <a:p>
-            <a:pPr algn="ctr"/>
-          </a:p>
-        </p:txBody>
-      </p:sp>
-      <p:sp>
-        <p:nvSpPr>
-          <p:cNvPr id="10" name="TextBox 9"/>
-          <p:cNvSpPr txBox="1"/>
-          <p:nvPr/>
-        </p:nvSpPr>
-        <p:spPr>
-          <a:xfrm>
-            <a:off x="685800" y="1600200"/>
-            <a:ext cx="3057753" cy="3749039"/>
-          </a:xfrm>
-          <a:prstGeom prst="rect">
-            <a:avLst/>
-          </a:prstGeom>
-          <a:noFill/>
-        </p:spPr>
-        <p:txBody>
-          <a:bodyPr wrap="square">
-            <a:spAutoFit/>
-          </a:bodyPr>
-          <a:lstStyle/>
-          <a:p>
-            <a:pPr>
+          <a:bodyPr rtlCol="0" anchor="ctr" wrap="square"/>
+          <a:lstStyle/>
+          <a:p>
+            <a:pPr algn="ctr">
+              <a:defRPr sz="3600" b="1">
+                <a:solidFill>
+                  <a:srgbClr val="D60000"/>
+                </a:solidFill>
+                <a:latin typeface="Outfit"/>
+              </a:defRPr>
+            </a:pPr>
+            <a:r>
+              <a:t>+15%</a:t>
+            </a:r>
+          </a:p>
+          <a:p>
+            <a:pPr algn="ctr">
               <a:spcAft>
                 <a:spcPts val="1400"/>
               </a:spcAft>
-              <a:defRPr sz="1300" b="1">
-                <a:solidFill>
-                  <a:srgbClr val="0F2537"/>
-                </a:solidFill>
-                <a:latin typeface="Outfit"/>
-              </a:defRPr>
-            </a:pPr>
-            <a:r>
-              <a:t>1. Core Capability &amp; Pain</a:t>
-            </a:r>
-          </a:p>
-          <a:p>
-            <a:pPr>
-              <a:spcAft>
-                <a:spcPts val="1200"/>
-              </a:spcAft>
-              <a:defRPr sz="1050">
+              <a:defRPr sz="950" b="1">
+                <a:solidFill>
+                  <a:srgbClr val="64748B"/>
+                </a:solidFill>
+                <a:latin typeface="Inter"/>
+              </a:defRPr>
+            </a:pPr>
+            <a:r>
+              <a:t>Solar Yield Boost</a:t>
+            </a:r>
+          </a:p>
+          <a:p>
+            <a:pPr algn="ctr">
+              <a:defRPr sz="950">
                 <a:solidFill>
                   <a:srgbClr val="1E293B"/>
                 </a:solidFill>
@@ -9978,20 +10148,20 @@
               </a:defRPr>
             </a:pPr>
             <a:r>
-              <a:t>Nature Grid solar panel installation contracts are one-time capital purchases. Customers lack transparency into active energy yields and degradation. JCS can design IoT analytics dashboards.</a:t>
-            </a:r>
-          </a:p>
-        </p:txBody>
-      </p:sp>
-      <p:sp>
-        <p:nvSpPr>
-          <p:cNvPr id="11" name="Right Arrow 10"/>
+              <a:t>Sensors track panel degradation, dust coverage, and ROI in real-time, preventing energy loss.</a:t>
+            </a:r>
+          </a:p>
+        </p:txBody>
+      </p:sp>
+      <p:sp>
+        <p:nvSpPr>
+          <p:cNvPr id="10" name="Right Arrow 9"/>
           <p:cNvSpPr/>
           <p:nvPr/>
         </p:nvSpPr>
         <p:spPr>
           <a:xfrm>
-            <a:off x="4017873" y="3291840"/>
+            <a:off x="4023360" y="3291840"/>
             <a:ext cx="274320" cy="182880"/>
           </a:xfrm>
           <a:prstGeom prst="rightArrow">
@@ -10028,13 +10198,13 @@
       </p:sp>
       <p:sp>
         <p:nvSpPr>
-          <p:cNvPr id="12" name="Rounded Rectangle 11"/>
+          <p:cNvPr id="11" name="Rounded Rectangle 10"/>
           <p:cNvSpPr/>
           <p:nvPr/>
         </p:nvSpPr>
         <p:spPr>
           <a:xfrm>
-            <a:off x="4429353" y="1508760"/>
+            <a:off x="4434840" y="1508760"/>
             <a:ext cx="3332073" cy="3931920"/>
           </a:xfrm>
           <a:prstGeom prst="roundRect">
@@ -10064,38 +10234,12 @@
           </a:fontRef>
         </p:style>
         <p:txBody>
-          <a:bodyPr rtlCol="0" anchor="ctr"/>
-          <a:lstStyle/>
-          <a:p>
-            <a:pPr algn="ctr"/>
-          </a:p>
-        </p:txBody>
-      </p:sp>
-      <p:sp>
-        <p:nvSpPr>
-          <p:cNvPr id="13" name="TextBox 12"/>
-          <p:cNvSpPr txBox="1"/>
-          <p:nvPr/>
-        </p:nvSpPr>
-        <p:spPr>
-          <a:xfrm>
-            <a:off x="4566513" y="1600200"/>
-            <a:ext cx="3057753" cy="3749039"/>
-          </a:xfrm>
-          <a:prstGeom prst="rect">
-            <a:avLst/>
-          </a:prstGeom>
-          <a:noFill/>
-        </p:spPr>
-        <p:txBody>
-          <a:bodyPr wrap="square">
-            <a:spAutoFit/>
-          </a:bodyPr>
-          <a:lstStyle/>
-          <a:p>
-            <a:pPr>
+          <a:bodyPr rtlCol="0" anchor="ctr" wrap="square"/>
+          <a:lstStyle/>
+          <a:p>
+            <a:pPr algn="ctr">
               <a:spcAft>
-                <a:spcPts val="1400"/>
+                <a:spcPts val="2000"/>
               </a:spcAft>
               <a:defRPr sz="1300" b="1">
                 <a:solidFill>
@@ -10105,15 +10249,12 @@
               </a:defRPr>
             </a:pPr>
             <a:r>
-              <a:t>2. The SaaS Solution</a:t>
-            </a:r>
-          </a:p>
-          <a:p>
-            <a:pPr>
-              <a:spcAft>
-                <a:spcPts val="1200"/>
-              </a:spcAft>
-              <a:defRPr sz="1050">
+              <a:t>JCS + Nature Grid Synergy</a:t>
+            </a:r>
+          </a:p>
+          <a:p>
+            <a:pPr algn="ctr">
+              <a:defRPr sz="950">
                 <a:solidFill>
                   <a:srgbClr val="1E293B"/>
                 </a:solidFill>
@@ -10121,20 +10262,20 @@
               </a:defRPr>
             </a:pPr>
             <a:r>
-              <a:t>An IoT monitoring panel telemetry software. Tracks active output (kW) and daily counts (kWh). Automatically detects dust, triggering cleanings and scheduling maintenance dispatches.</a:t>
-            </a:r>
-          </a:p>
-        </p:txBody>
-      </p:sp>
-      <p:sp>
-        <p:nvSpPr>
-          <p:cNvPr id="14" name="Right Arrow 13"/>
+              <a:t>JCS engineers active telemetry cloud databases. Nature Grid embeds sensors with C&amp;I panels and cleans panels with O&amp;M field dispatch crews.</a:t>
+            </a:r>
+          </a:p>
+        </p:txBody>
+      </p:sp>
+      <p:sp>
+        <p:nvSpPr>
+          <p:cNvPr id="12" name="Right Arrow 11"/>
           <p:cNvSpPr/>
           <p:nvPr/>
         </p:nvSpPr>
         <p:spPr>
           <a:xfrm>
-            <a:off x="7898586" y="3291840"/>
+            <a:off x="7909560" y="3291840"/>
             <a:ext cx="274320" cy="182880"/>
           </a:xfrm>
           <a:prstGeom prst="rightArrow">
@@ -10171,13 +10312,13 @@
       </p:sp>
       <p:sp>
         <p:nvSpPr>
-          <p:cNvPr id="15" name="Rounded Rectangle 14"/>
+          <p:cNvPr id="13" name="Rounded Rectangle 12"/>
           <p:cNvSpPr/>
           <p:nvPr/>
         </p:nvSpPr>
         <p:spPr>
           <a:xfrm>
-            <a:off x="8310066" y="1508760"/>
+            <a:off x="8321040" y="1508760"/>
             <a:ext cx="3332073" cy="3931920"/>
           </a:xfrm>
           <a:prstGeom prst="roundRect">
@@ -10207,56 +10348,40 @@
           </a:fontRef>
         </p:style>
         <p:txBody>
-          <a:bodyPr rtlCol="0" anchor="ctr"/>
-          <a:lstStyle/>
-          <a:p>
-            <a:pPr algn="ctr"/>
-          </a:p>
-        </p:txBody>
-      </p:sp>
-      <p:sp>
-        <p:nvSpPr>
-          <p:cNvPr id="16" name="TextBox 15"/>
-          <p:cNvSpPr txBox="1"/>
-          <p:nvPr/>
-        </p:nvSpPr>
-        <p:spPr>
-          <a:xfrm>
-            <a:off x="8447226" y="1600200"/>
-            <a:ext cx="3057753" cy="3749039"/>
-          </a:xfrm>
-          <a:prstGeom prst="rect">
-            <a:avLst/>
-          </a:prstGeom>
-          <a:noFill/>
-        </p:spPr>
-        <p:txBody>
-          <a:bodyPr wrap="square">
-            <a:spAutoFit/>
-          </a:bodyPr>
-          <a:lstStyle/>
-          <a:p>
-            <a:pPr>
+          <a:bodyPr rtlCol="0" anchor="ctr" wrap="square"/>
+          <a:lstStyle/>
+          <a:p>
+            <a:pPr algn="ctr">
+              <a:defRPr sz="3600" b="1">
+                <a:solidFill>
+                  <a:srgbClr val="0284C7"/>
+                </a:solidFill>
+                <a:latin typeface="Outfit"/>
+              </a:defRPr>
+            </a:pPr>
+            <a:r>
+              <a:t>100%</a:t>
+            </a:r>
+          </a:p>
+          <a:p>
+            <a:pPr algn="ctr">
               <a:spcAft>
                 <a:spcPts val="1400"/>
               </a:spcAft>
-              <a:defRPr sz="1300" b="1">
-                <a:solidFill>
-                  <a:srgbClr val="0284C7"/>
-                </a:solidFill>
-                <a:latin typeface="Outfit"/>
-              </a:defRPr>
-            </a:pPr>
-            <a:r>
-              <a:t>3. Target Economics</a:t>
-            </a:r>
-          </a:p>
-          <a:p>
-            <a:pPr>
-              <a:spcAft>
-                <a:spcPts val="1200"/>
-              </a:spcAft>
-              <a:defRPr sz="1050">
+              <a:defRPr sz="950" b="1">
+                <a:solidFill>
+                  <a:srgbClr val="64748B"/>
+                </a:solidFill>
+                <a:latin typeface="Inter"/>
+              </a:defRPr>
+            </a:pPr>
+            <a:r>
+              <a:t>Live Telemetry</a:t>
+            </a:r>
+          </a:p>
+          <a:p>
+            <a:pPr algn="ctr">
+              <a:defRPr sz="950">
                 <a:solidFill>
                   <a:srgbClr val="1E293B"/>
                 </a:solidFill>
@@ -10264,7 +10389,7 @@
               </a:defRPr>
             </a:pPr>
             <a:r>
-              <a:t>Secures multi-year predictive maintenance agreements. Boosts panel yields by 15%, transforming transactional sales into high-margin recurring retainers.</a:t>
+              <a:t>Transforms transactional one-time hardware sales into multi-year recurring service and maintenance retainers.</a:t>
             </a:r>
           </a:p>
         </p:txBody>
@@ -10446,7 +10571,7 @@
         </p:nvSpPr>
         <p:spPr>
           <a:xfrm>
-            <a:off x="548640" y="5623560"/>
+            <a:off x="548640" y="5577840"/>
             <a:ext cx="11094415" cy="594360"/>
           </a:xfrm>
           <a:prstGeom prst="rect">
@@ -10489,7 +10614,7 @@
         </p:nvSpPr>
         <p:spPr>
           <a:xfrm>
-            <a:off x="548640" y="5623560"/>
+            <a:off x="548640" y="5577840"/>
             <a:ext cx="73152" cy="594360"/>
           </a:xfrm>
           <a:prstGeom prst="rect">
@@ -10532,7 +10657,7 @@
         </p:nvSpPr>
         <p:spPr>
           <a:xfrm>
-            <a:off x="731520" y="5669280"/>
+            <a:off x="731520" y="5623560"/>
             <a:ext cx="10698480" cy="502920"/>
           </a:xfrm>
           <a:prstGeom prst="rect">
@@ -11033,7 +11158,7 @@
         </p:nvSpPr>
         <p:spPr>
           <a:xfrm>
-            <a:off x="548640" y="5623560"/>
+            <a:off x="548640" y="5577840"/>
             <a:ext cx="11094415" cy="594360"/>
           </a:xfrm>
           <a:prstGeom prst="rect">
@@ -11076,7 +11201,7 @@
         </p:nvSpPr>
         <p:spPr>
           <a:xfrm>
-            <a:off x="548640" y="5623560"/>
+            <a:off x="548640" y="5577840"/>
             <a:ext cx="73152" cy="594360"/>
           </a:xfrm>
           <a:prstGeom prst="rect">
@@ -11119,7 +11244,7 @@
         </p:nvSpPr>
         <p:spPr>
           <a:xfrm>
-            <a:off x="731520" y="5669280"/>
+            <a:off x="731520" y="5623560"/>
             <a:ext cx="10698480" cy="502920"/>
           </a:xfrm>
           <a:prstGeom prst="rect">
@@ -11220,7 +11345,7 @@
               </a:spcAft>
               <a:defRPr sz="850" b="1">
                 <a:solidFill>
-                  <a:srgbClr val="64748B"/>
+                  <a:srgbClr val="0284C7"/>
                 </a:solidFill>
                 <a:latin typeface="Inter"/>
               </a:defRPr>

</xml_diff>